<commit_message>
Update documentation for RTT
</commit_message>
<xml_diff>
--- a/documentation/doxygen/src/images/blocks.pptx
+++ b/documentation/doxygen/src/images/blocks.pptx
@@ -273,7 +273,7 @@
           <a:p>
             <a:fld id="{E1BCA6AF-7F69-456D-BB79-EC94A44BF887}" type="datetimeFigureOut">
               <a:rPr lang="en-US" smtClean="0"/>
-              <a:t>1/26/2026</a:t>
+              <a:t>6/8/2026</a:t>
             </a:fld>
             <a:endParaRPr lang="en-US"/>
           </a:p>
@@ -471,7 +471,7 @@
           <a:p>
             <a:fld id="{E1BCA6AF-7F69-456D-BB79-EC94A44BF887}" type="datetimeFigureOut">
               <a:rPr lang="en-US" smtClean="0"/>
-              <a:t>1/26/2026</a:t>
+              <a:t>6/8/2026</a:t>
             </a:fld>
             <a:endParaRPr lang="en-US"/>
           </a:p>
@@ -679,7 +679,7 @@
           <a:p>
             <a:fld id="{E1BCA6AF-7F69-456D-BB79-EC94A44BF887}" type="datetimeFigureOut">
               <a:rPr lang="en-US" smtClean="0"/>
-              <a:t>1/26/2026</a:t>
+              <a:t>6/8/2026</a:t>
             </a:fld>
             <a:endParaRPr lang="en-US"/>
           </a:p>
@@ -877,7 +877,7 @@
           <a:p>
             <a:fld id="{E1BCA6AF-7F69-456D-BB79-EC94A44BF887}" type="datetimeFigureOut">
               <a:rPr lang="en-US" smtClean="0"/>
-              <a:t>1/26/2026</a:t>
+              <a:t>6/8/2026</a:t>
             </a:fld>
             <a:endParaRPr lang="en-US"/>
           </a:p>
@@ -1152,7 +1152,7 @@
           <a:p>
             <a:fld id="{E1BCA6AF-7F69-456D-BB79-EC94A44BF887}" type="datetimeFigureOut">
               <a:rPr lang="en-US" smtClean="0"/>
-              <a:t>1/26/2026</a:t>
+              <a:t>6/8/2026</a:t>
             </a:fld>
             <a:endParaRPr lang="en-US"/>
           </a:p>
@@ -1417,7 +1417,7 @@
           <a:p>
             <a:fld id="{E1BCA6AF-7F69-456D-BB79-EC94A44BF887}" type="datetimeFigureOut">
               <a:rPr lang="en-US" smtClean="0"/>
-              <a:t>1/26/2026</a:t>
+              <a:t>6/8/2026</a:t>
             </a:fld>
             <a:endParaRPr lang="en-US"/>
           </a:p>
@@ -1829,7 +1829,7 @@
           <a:p>
             <a:fld id="{E1BCA6AF-7F69-456D-BB79-EC94A44BF887}" type="datetimeFigureOut">
               <a:rPr lang="en-US" smtClean="0"/>
-              <a:t>1/26/2026</a:t>
+              <a:t>6/8/2026</a:t>
             </a:fld>
             <a:endParaRPr lang="en-US"/>
           </a:p>
@@ -1970,7 +1970,7 @@
           <a:p>
             <a:fld id="{E1BCA6AF-7F69-456D-BB79-EC94A44BF887}" type="datetimeFigureOut">
               <a:rPr lang="en-US" smtClean="0"/>
-              <a:t>1/26/2026</a:t>
+              <a:t>6/8/2026</a:t>
             </a:fld>
             <a:endParaRPr lang="en-US"/>
           </a:p>
@@ -2083,7 +2083,7 @@
           <a:p>
             <a:fld id="{E1BCA6AF-7F69-456D-BB79-EC94A44BF887}" type="datetimeFigureOut">
               <a:rPr lang="en-US" smtClean="0"/>
-              <a:t>1/26/2026</a:t>
+              <a:t>6/8/2026</a:t>
             </a:fld>
             <a:endParaRPr lang="en-US"/>
           </a:p>
@@ -2394,7 +2394,7 @@
           <a:p>
             <a:fld id="{E1BCA6AF-7F69-456D-BB79-EC94A44BF887}" type="datetimeFigureOut">
               <a:rPr lang="en-US" smtClean="0"/>
-              <a:t>1/26/2026</a:t>
+              <a:t>6/8/2026</a:t>
             </a:fld>
             <a:endParaRPr lang="en-US"/>
           </a:p>
@@ -2682,7 +2682,7 @@
           <a:p>
             <a:fld id="{E1BCA6AF-7F69-456D-BB79-EC94A44BF887}" type="datetimeFigureOut">
               <a:rPr lang="en-US" smtClean="0"/>
-              <a:t>1/26/2026</a:t>
+              <a:t>6/8/2026</a:t>
             </a:fld>
             <a:endParaRPr lang="en-US"/>
           </a:p>
@@ -2923,7 +2923,7 @@
           <a:p>
             <a:fld id="{E1BCA6AF-7F69-456D-BB79-EC94A44BF887}" type="datetimeFigureOut">
               <a:rPr lang="en-US" smtClean="0"/>
-              <a:t>1/26/2026</a:t>
+              <a:t>6/8/2026</a:t>
             </a:fld>
             <a:endParaRPr lang="en-US"/>
           </a:p>
@@ -5790,7 +5790,7 @@
         <p:spPr>
           <a:xfrm>
             <a:off x="363274" y="288277"/>
-            <a:ext cx="2945983" cy="4096687"/>
+            <a:ext cx="2945983" cy="4588523"/>
           </a:xfrm>
           <a:prstGeom prst="rect">
             <a:avLst/>
@@ -5992,7 +5992,7 @@
         <p:spPr>
           <a:xfrm>
             <a:off x="1004146" y="1491972"/>
-            <a:ext cx="1996554" cy="2699028"/>
+            <a:ext cx="1996554" cy="3183937"/>
           </a:xfrm>
           <a:prstGeom prst="rect">
             <a:avLst/>
@@ -6252,7 +6252,7 @@
               <a:rPr lang="en-US" sz="1200" dirty="0">
                 <a:latin typeface="Consolas" panose="020B0609020204030204" pitchFamily="49" charset="0"/>
               </a:rPr>
-              <a:t>UART</a:t>
+              <a:t>RTT</a:t>
             </a:r>
           </a:p>
         </p:txBody>
@@ -6638,6 +6638,63 @@
         <p:spPr>
           <a:xfrm>
             <a:off x="1194700" y="3645899"/>
+            <a:ext cx="1615439" cy="364464"/>
+          </a:xfrm>
+          <a:prstGeom prst="rect">
+            <a:avLst/>
+          </a:prstGeom>
+          <a:solidFill>
+            <a:schemeClr val="tx2"/>
+          </a:solidFill>
+          <a:ln>
+            <a:noFill/>
+          </a:ln>
+        </p:spPr>
+        <p:style>
+          <a:lnRef idx="2">
+            <a:schemeClr val="accent1">
+              <a:shade val="50000"/>
+            </a:schemeClr>
+          </a:lnRef>
+          <a:fillRef idx="1">
+            <a:schemeClr val="accent1"/>
+          </a:fillRef>
+          <a:effectRef idx="0">
+            <a:schemeClr val="accent1"/>
+          </a:effectRef>
+          <a:fontRef idx="minor">
+            <a:schemeClr val="lt1"/>
+          </a:fontRef>
+        </p:style>
+        <p:txBody>
+          <a:bodyPr rtlCol="0" anchor="ctr"/>
+          <a:lstStyle/>
+          <a:p>
+            <a:pPr algn="ctr"/>
+            <a:r>
+              <a:rPr lang="en-US" sz="1200" dirty="0">
+                <a:latin typeface="Consolas" panose="020B0609020204030204" pitchFamily="49" charset="0"/>
+              </a:rPr>
+              <a:t>UART</a:t>
+            </a:r>
+          </a:p>
+        </p:txBody>
+      </p:sp>
+      <p:sp>
+        <p:nvSpPr>
+          <p:cNvPr id="11" name="Rectangle 10">
+            <a:extLst>
+              <a:ext uri="{FF2B5EF4-FFF2-40B4-BE49-F238E27FC236}">
+                <a16:creationId xmlns:a16="http://schemas.microsoft.com/office/drawing/2014/main" id="{6DA4F40F-DB94-3446-16A2-F6138EB26A4C}"/>
+              </a:ext>
+            </a:extLst>
+          </p:cNvPr>
+          <p:cNvSpPr/>
+          <p:nvPr/>
+        </p:nvSpPr>
+        <p:spPr>
+          <a:xfrm>
+            <a:off x="1194700" y="4137464"/>
             <a:ext cx="1615439" cy="364464"/>
           </a:xfrm>
           <a:prstGeom prst="rect">

</xml_diff>

<commit_message>
Update documentation for RTT (#85)
Resolves https://github.com/ARM-software/CMSIS-Compiler/issues/73
</commit_message>
<xml_diff>
--- a/documentation/doxygen/src/images/blocks.pptx
+++ b/documentation/doxygen/src/images/blocks.pptx
@@ -273,7 +273,7 @@
           <a:p>
             <a:fld id="{E1BCA6AF-7F69-456D-BB79-EC94A44BF887}" type="datetimeFigureOut">
               <a:rPr lang="en-US" smtClean="0"/>
-              <a:t>1/26/2026</a:t>
+              <a:t>6/8/2026</a:t>
             </a:fld>
             <a:endParaRPr lang="en-US"/>
           </a:p>
@@ -471,7 +471,7 @@
           <a:p>
             <a:fld id="{E1BCA6AF-7F69-456D-BB79-EC94A44BF887}" type="datetimeFigureOut">
               <a:rPr lang="en-US" smtClean="0"/>
-              <a:t>1/26/2026</a:t>
+              <a:t>6/8/2026</a:t>
             </a:fld>
             <a:endParaRPr lang="en-US"/>
           </a:p>
@@ -679,7 +679,7 @@
           <a:p>
             <a:fld id="{E1BCA6AF-7F69-456D-BB79-EC94A44BF887}" type="datetimeFigureOut">
               <a:rPr lang="en-US" smtClean="0"/>
-              <a:t>1/26/2026</a:t>
+              <a:t>6/8/2026</a:t>
             </a:fld>
             <a:endParaRPr lang="en-US"/>
           </a:p>
@@ -877,7 +877,7 @@
           <a:p>
             <a:fld id="{E1BCA6AF-7F69-456D-BB79-EC94A44BF887}" type="datetimeFigureOut">
               <a:rPr lang="en-US" smtClean="0"/>
-              <a:t>1/26/2026</a:t>
+              <a:t>6/8/2026</a:t>
             </a:fld>
             <a:endParaRPr lang="en-US"/>
           </a:p>
@@ -1152,7 +1152,7 @@
           <a:p>
             <a:fld id="{E1BCA6AF-7F69-456D-BB79-EC94A44BF887}" type="datetimeFigureOut">
               <a:rPr lang="en-US" smtClean="0"/>
-              <a:t>1/26/2026</a:t>
+              <a:t>6/8/2026</a:t>
             </a:fld>
             <a:endParaRPr lang="en-US"/>
           </a:p>
@@ -1417,7 +1417,7 @@
           <a:p>
             <a:fld id="{E1BCA6AF-7F69-456D-BB79-EC94A44BF887}" type="datetimeFigureOut">
               <a:rPr lang="en-US" smtClean="0"/>
-              <a:t>1/26/2026</a:t>
+              <a:t>6/8/2026</a:t>
             </a:fld>
             <a:endParaRPr lang="en-US"/>
           </a:p>
@@ -1829,7 +1829,7 @@
           <a:p>
             <a:fld id="{E1BCA6AF-7F69-456D-BB79-EC94A44BF887}" type="datetimeFigureOut">
               <a:rPr lang="en-US" smtClean="0"/>
-              <a:t>1/26/2026</a:t>
+              <a:t>6/8/2026</a:t>
             </a:fld>
             <a:endParaRPr lang="en-US"/>
           </a:p>
@@ -1970,7 +1970,7 @@
           <a:p>
             <a:fld id="{E1BCA6AF-7F69-456D-BB79-EC94A44BF887}" type="datetimeFigureOut">
               <a:rPr lang="en-US" smtClean="0"/>
-              <a:t>1/26/2026</a:t>
+              <a:t>6/8/2026</a:t>
             </a:fld>
             <a:endParaRPr lang="en-US"/>
           </a:p>
@@ -2083,7 +2083,7 @@
           <a:p>
             <a:fld id="{E1BCA6AF-7F69-456D-BB79-EC94A44BF887}" type="datetimeFigureOut">
               <a:rPr lang="en-US" smtClean="0"/>
-              <a:t>1/26/2026</a:t>
+              <a:t>6/8/2026</a:t>
             </a:fld>
             <a:endParaRPr lang="en-US"/>
           </a:p>
@@ -2394,7 +2394,7 @@
           <a:p>
             <a:fld id="{E1BCA6AF-7F69-456D-BB79-EC94A44BF887}" type="datetimeFigureOut">
               <a:rPr lang="en-US" smtClean="0"/>
-              <a:t>1/26/2026</a:t>
+              <a:t>6/8/2026</a:t>
             </a:fld>
             <a:endParaRPr lang="en-US"/>
           </a:p>
@@ -2682,7 +2682,7 @@
           <a:p>
             <a:fld id="{E1BCA6AF-7F69-456D-BB79-EC94A44BF887}" type="datetimeFigureOut">
               <a:rPr lang="en-US" smtClean="0"/>
-              <a:t>1/26/2026</a:t>
+              <a:t>6/8/2026</a:t>
             </a:fld>
             <a:endParaRPr lang="en-US"/>
           </a:p>
@@ -2923,7 +2923,7 @@
           <a:p>
             <a:fld id="{E1BCA6AF-7F69-456D-BB79-EC94A44BF887}" type="datetimeFigureOut">
               <a:rPr lang="en-US" smtClean="0"/>
-              <a:t>1/26/2026</a:t>
+              <a:t>6/8/2026</a:t>
             </a:fld>
             <a:endParaRPr lang="en-US"/>
           </a:p>
@@ -5790,7 +5790,7 @@
         <p:spPr>
           <a:xfrm>
             <a:off x="363274" y="288277"/>
-            <a:ext cx="2945983" cy="4096687"/>
+            <a:ext cx="2945983" cy="4588523"/>
           </a:xfrm>
           <a:prstGeom prst="rect">
             <a:avLst/>
@@ -5992,7 +5992,7 @@
         <p:spPr>
           <a:xfrm>
             <a:off x="1004146" y="1491972"/>
-            <a:ext cx="1996554" cy="2699028"/>
+            <a:ext cx="1996554" cy="3183937"/>
           </a:xfrm>
           <a:prstGeom prst="rect">
             <a:avLst/>
@@ -6252,7 +6252,7 @@
               <a:rPr lang="en-US" sz="1200" dirty="0">
                 <a:latin typeface="Consolas" panose="020B0609020204030204" pitchFamily="49" charset="0"/>
               </a:rPr>
-              <a:t>UART</a:t>
+              <a:t>RTT</a:t>
             </a:r>
           </a:p>
         </p:txBody>
@@ -6638,6 +6638,63 @@
         <p:spPr>
           <a:xfrm>
             <a:off x="1194700" y="3645899"/>
+            <a:ext cx="1615439" cy="364464"/>
+          </a:xfrm>
+          <a:prstGeom prst="rect">
+            <a:avLst/>
+          </a:prstGeom>
+          <a:solidFill>
+            <a:schemeClr val="tx2"/>
+          </a:solidFill>
+          <a:ln>
+            <a:noFill/>
+          </a:ln>
+        </p:spPr>
+        <p:style>
+          <a:lnRef idx="2">
+            <a:schemeClr val="accent1">
+              <a:shade val="50000"/>
+            </a:schemeClr>
+          </a:lnRef>
+          <a:fillRef idx="1">
+            <a:schemeClr val="accent1"/>
+          </a:fillRef>
+          <a:effectRef idx="0">
+            <a:schemeClr val="accent1"/>
+          </a:effectRef>
+          <a:fontRef idx="minor">
+            <a:schemeClr val="lt1"/>
+          </a:fontRef>
+        </p:style>
+        <p:txBody>
+          <a:bodyPr rtlCol="0" anchor="ctr"/>
+          <a:lstStyle/>
+          <a:p>
+            <a:pPr algn="ctr"/>
+            <a:r>
+              <a:rPr lang="en-US" sz="1200" dirty="0">
+                <a:latin typeface="Consolas" panose="020B0609020204030204" pitchFamily="49" charset="0"/>
+              </a:rPr>
+              <a:t>UART</a:t>
+            </a:r>
+          </a:p>
+        </p:txBody>
+      </p:sp>
+      <p:sp>
+        <p:nvSpPr>
+          <p:cNvPr id="11" name="Rectangle 10">
+            <a:extLst>
+              <a:ext uri="{FF2B5EF4-FFF2-40B4-BE49-F238E27FC236}">
+                <a16:creationId xmlns:a16="http://schemas.microsoft.com/office/drawing/2014/main" id="{6DA4F40F-DB94-3446-16A2-F6138EB26A4C}"/>
+              </a:ext>
+            </a:extLst>
+          </p:cNvPr>
+          <p:cNvSpPr/>
+          <p:nvPr/>
+        </p:nvSpPr>
+        <p:spPr>
+          <a:xfrm>
+            <a:off x="1194700" y="4137464"/>
             <a:ext cx="1615439" cy="364464"/>
           </a:xfrm>
           <a:prstGeom prst="rect">

</xml_diff>

<commit_message>
UART/RTT added to Overview.md
</commit_message>
<xml_diff>
--- a/documentation/doxygen/src/images/blocks.pptx
+++ b/documentation/doxygen/src/images/blocks.pptx
@@ -9,6 +9,7 @@
     <p:sldId id="258" r:id="rId3"/>
     <p:sldId id="259" r:id="rId4"/>
     <p:sldId id="257" r:id="rId5"/>
+    <p:sldId id="2147479589" r:id="rId6"/>
   </p:sldIdLst>
   <p:sldSz cx="12192000" cy="6858000"/>
   <p:notesSz cx="6858000" cy="9144000"/>
@@ -273,7 +274,7 @@
           <a:p>
             <a:fld id="{E1BCA6AF-7F69-456D-BB79-EC94A44BF887}" type="datetimeFigureOut">
               <a:rPr lang="en-US" smtClean="0"/>
-              <a:t>6/8/2026</a:t>
+              <a:t>6/9/2026</a:t>
             </a:fld>
             <a:endParaRPr lang="en-US"/>
           </a:p>
@@ -471,7 +472,7 @@
           <a:p>
             <a:fld id="{E1BCA6AF-7F69-456D-BB79-EC94A44BF887}" type="datetimeFigureOut">
               <a:rPr lang="en-US" smtClean="0"/>
-              <a:t>6/8/2026</a:t>
+              <a:t>6/9/2026</a:t>
             </a:fld>
             <a:endParaRPr lang="en-US"/>
           </a:p>
@@ -679,7 +680,7 @@
           <a:p>
             <a:fld id="{E1BCA6AF-7F69-456D-BB79-EC94A44BF887}" type="datetimeFigureOut">
               <a:rPr lang="en-US" smtClean="0"/>
-              <a:t>6/8/2026</a:t>
+              <a:t>6/9/2026</a:t>
             </a:fld>
             <a:endParaRPr lang="en-US"/>
           </a:p>
@@ -877,7 +878,7 @@
           <a:p>
             <a:fld id="{E1BCA6AF-7F69-456D-BB79-EC94A44BF887}" type="datetimeFigureOut">
               <a:rPr lang="en-US" smtClean="0"/>
-              <a:t>6/8/2026</a:t>
+              <a:t>6/9/2026</a:t>
             </a:fld>
             <a:endParaRPr lang="en-US"/>
           </a:p>
@@ -1152,7 +1153,7 @@
           <a:p>
             <a:fld id="{E1BCA6AF-7F69-456D-BB79-EC94A44BF887}" type="datetimeFigureOut">
               <a:rPr lang="en-US" smtClean="0"/>
-              <a:t>6/8/2026</a:t>
+              <a:t>6/9/2026</a:t>
             </a:fld>
             <a:endParaRPr lang="en-US"/>
           </a:p>
@@ -1417,7 +1418,7 @@
           <a:p>
             <a:fld id="{E1BCA6AF-7F69-456D-BB79-EC94A44BF887}" type="datetimeFigureOut">
               <a:rPr lang="en-US" smtClean="0"/>
-              <a:t>6/8/2026</a:t>
+              <a:t>6/9/2026</a:t>
             </a:fld>
             <a:endParaRPr lang="en-US"/>
           </a:p>
@@ -1829,7 +1830,7 @@
           <a:p>
             <a:fld id="{E1BCA6AF-7F69-456D-BB79-EC94A44BF887}" type="datetimeFigureOut">
               <a:rPr lang="en-US" smtClean="0"/>
-              <a:t>6/8/2026</a:t>
+              <a:t>6/9/2026</a:t>
             </a:fld>
             <a:endParaRPr lang="en-US"/>
           </a:p>
@@ -1970,7 +1971,7 @@
           <a:p>
             <a:fld id="{E1BCA6AF-7F69-456D-BB79-EC94A44BF887}" type="datetimeFigureOut">
               <a:rPr lang="en-US" smtClean="0"/>
-              <a:t>6/8/2026</a:t>
+              <a:t>6/9/2026</a:t>
             </a:fld>
             <a:endParaRPr lang="en-US"/>
           </a:p>
@@ -2083,7 +2084,7 @@
           <a:p>
             <a:fld id="{E1BCA6AF-7F69-456D-BB79-EC94A44BF887}" type="datetimeFigureOut">
               <a:rPr lang="en-US" smtClean="0"/>
-              <a:t>6/8/2026</a:t>
+              <a:t>6/9/2026</a:t>
             </a:fld>
             <a:endParaRPr lang="en-US"/>
           </a:p>
@@ -2394,7 +2395,7 @@
           <a:p>
             <a:fld id="{E1BCA6AF-7F69-456D-BB79-EC94A44BF887}" type="datetimeFigureOut">
               <a:rPr lang="en-US" smtClean="0"/>
-              <a:t>6/8/2026</a:t>
+              <a:t>6/9/2026</a:t>
             </a:fld>
             <a:endParaRPr lang="en-US"/>
           </a:p>
@@ -2682,7 +2683,7 @@
           <a:p>
             <a:fld id="{E1BCA6AF-7F69-456D-BB79-EC94A44BF887}" type="datetimeFigureOut">
               <a:rPr lang="en-US" smtClean="0"/>
-              <a:t>6/8/2026</a:t>
+              <a:t>6/9/2026</a:t>
             </a:fld>
             <a:endParaRPr lang="en-US"/>
           </a:p>
@@ -2923,7 +2924,7 @@
           <a:p>
             <a:fld id="{E1BCA6AF-7F69-456D-BB79-EC94A44BF887}" type="datetimeFigureOut">
               <a:rPr lang="en-US" smtClean="0"/>
-              <a:t>6/8/2026</a:t>
+              <a:t>6/9/2026</a:t>
             </a:fld>
             <a:endParaRPr lang="en-US"/>
           </a:p>
@@ -7556,6 +7557,1218 @@
 </p:sld>
 </file>
 
+<file path=ppt/slides/slide5.xml><?xml version="1.0" encoding="utf-8"?>
+<p:sld xmlns:a="http://schemas.openxmlformats.org/drawingml/2006/main" xmlns:r="http://schemas.openxmlformats.org/officeDocument/2006/relationships" xmlns:p="http://schemas.openxmlformats.org/presentationml/2006/main">
+  <p:cSld>
+    <p:spTree>
+      <p:nvGrpSpPr>
+        <p:cNvPr id="1" name=""/>
+        <p:cNvGrpSpPr/>
+        <p:nvPr/>
+      </p:nvGrpSpPr>
+      <p:grpSpPr>
+        <a:xfrm>
+          <a:off x="0" y="0"/>
+          <a:ext cx="0" cy="0"/>
+          <a:chOff x="0" y="0"/>
+          <a:chExt cx="0" cy="0"/>
+        </a:xfrm>
+      </p:grpSpPr>
+      <p:sp>
+        <p:nvSpPr>
+          <p:cNvPr id="27" name="Rectangle 26">
+            <a:extLst>
+              <a:ext uri="{FF2B5EF4-FFF2-40B4-BE49-F238E27FC236}">
+                <a16:creationId xmlns:a16="http://schemas.microsoft.com/office/drawing/2014/main" id="{5E833238-6923-12C5-973E-42A3CE64562B}"/>
+              </a:ext>
+            </a:extLst>
+          </p:cNvPr>
+          <p:cNvSpPr/>
+          <p:nvPr/>
+        </p:nvSpPr>
+        <p:spPr>
+          <a:xfrm>
+            <a:off x="6977425" y="1662086"/>
+            <a:ext cx="1248803" cy="1196372"/>
+          </a:xfrm>
+          <a:prstGeom prst="rect">
+            <a:avLst/>
+          </a:prstGeom>
+          <a:solidFill>
+            <a:schemeClr val="bg1">
+              <a:lumMod val="95000"/>
+            </a:schemeClr>
+          </a:solidFill>
+          <a:ln>
+            <a:noFill/>
+          </a:ln>
+        </p:spPr>
+        <p:style>
+          <a:lnRef idx="2">
+            <a:schemeClr val="accent1">
+              <a:shade val="50000"/>
+            </a:schemeClr>
+          </a:lnRef>
+          <a:fillRef idx="1">
+            <a:schemeClr val="accent1"/>
+          </a:fillRef>
+          <a:effectRef idx="0">
+            <a:schemeClr val="accent1"/>
+          </a:effectRef>
+          <a:fontRef idx="minor">
+            <a:schemeClr val="lt1"/>
+          </a:fontRef>
+        </p:style>
+        <p:txBody>
+          <a:bodyPr rtlCol="0" anchor="b"/>
+          <a:lstStyle/>
+          <a:p>
+            <a:pPr algn="ctr"/>
+            <a:r>
+              <a:rPr lang="en-US" sz="1200" dirty="0">
+                <a:solidFill>
+                  <a:schemeClr val="tx1">
+                    <a:lumMod val="50000"/>
+                    <a:lumOff val="50000"/>
+                  </a:schemeClr>
+                </a:solidFill>
+              </a:rPr>
+              <a:t>Host Computer</a:t>
+            </a:r>
+          </a:p>
+        </p:txBody>
+      </p:sp>
+      <p:sp>
+        <p:nvSpPr>
+          <p:cNvPr id="17" name="Rectangle 16">
+            <a:extLst>
+              <a:ext uri="{FF2B5EF4-FFF2-40B4-BE49-F238E27FC236}">
+                <a16:creationId xmlns:a16="http://schemas.microsoft.com/office/drawing/2014/main" id="{6076D244-D973-C4F8-EDE1-74AC971E58AE}"/>
+              </a:ext>
+            </a:extLst>
+          </p:cNvPr>
+          <p:cNvSpPr/>
+          <p:nvPr/>
+        </p:nvSpPr>
+        <p:spPr>
+          <a:xfrm>
+            <a:off x="4596239" y="1661984"/>
+            <a:ext cx="1248803" cy="1196372"/>
+          </a:xfrm>
+          <a:prstGeom prst="rect">
+            <a:avLst/>
+          </a:prstGeom>
+          <a:solidFill>
+            <a:schemeClr val="bg1">
+              <a:lumMod val="95000"/>
+            </a:schemeClr>
+          </a:solidFill>
+          <a:ln>
+            <a:noFill/>
+          </a:ln>
+        </p:spPr>
+        <p:style>
+          <a:lnRef idx="2">
+            <a:schemeClr val="accent1">
+              <a:shade val="50000"/>
+            </a:schemeClr>
+          </a:lnRef>
+          <a:fillRef idx="1">
+            <a:schemeClr val="accent1"/>
+          </a:fillRef>
+          <a:effectRef idx="0">
+            <a:schemeClr val="accent1"/>
+          </a:effectRef>
+          <a:fontRef idx="minor">
+            <a:schemeClr val="lt1"/>
+          </a:fontRef>
+        </p:style>
+        <p:txBody>
+          <a:bodyPr rtlCol="0" anchor="b"/>
+          <a:lstStyle/>
+          <a:p>
+            <a:pPr algn="ctr"/>
+            <a:r>
+              <a:rPr lang="en-US" sz="1200" dirty="0">
+                <a:solidFill>
+                  <a:schemeClr val="tx1">
+                    <a:lumMod val="50000"/>
+                    <a:lumOff val="50000"/>
+                  </a:schemeClr>
+                </a:solidFill>
+              </a:rPr>
+              <a:t>Target Hardware</a:t>
+            </a:r>
+          </a:p>
+        </p:txBody>
+      </p:sp>
+      <p:sp>
+        <p:nvSpPr>
+          <p:cNvPr id="15" name="Rectangle 14">
+            <a:extLst>
+              <a:ext uri="{FF2B5EF4-FFF2-40B4-BE49-F238E27FC236}">
+                <a16:creationId xmlns:a16="http://schemas.microsoft.com/office/drawing/2014/main" id="{B4F6932C-E078-F0DF-B2C8-A3A2270ADEFC}"/>
+              </a:ext>
+            </a:extLst>
+          </p:cNvPr>
+          <p:cNvSpPr/>
+          <p:nvPr/>
+        </p:nvSpPr>
+        <p:spPr>
+          <a:xfrm>
+            <a:off x="1469151" y="1661984"/>
+            <a:ext cx="1248803" cy="1196372"/>
+          </a:xfrm>
+          <a:prstGeom prst="rect">
+            <a:avLst/>
+          </a:prstGeom>
+          <a:solidFill>
+            <a:schemeClr val="bg1">
+              <a:lumMod val="95000"/>
+            </a:schemeClr>
+          </a:solidFill>
+          <a:ln>
+            <a:noFill/>
+          </a:ln>
+        </p:spPr>
+        <p:style>
+          <a:lnRef idx="2">
+            <a:schemeClr val="accent1">
+              <a:shade val="50000"/>
+            </a:schemeClr>
+          </a:lnRef>
+          <a:fillRef idx="1">
+            <a:schemeClr val="accent1"/>
+          </a:fillRef>
+          <a:effectRef idx="0">
+            <a:schemeClr val="accent1"/>
+          </a:effectRef>
+          <a:fontRef idx="minor">
+            <a:schemeClr val="lt1"/>
+          </a:fontRef>
+        </p:style>
+        <p:txBody>
+          <a:bodyPr rtlCol="0" anchor="b"/>
+          <a:lstStyle/>
+          <a:p>
+            <a:pPr algn="ctr"/>
+            <a:r>
+              <a:rPr lang="en-US" sz="1200" dirty="0">
+                <a:solidFill>
+                  <a:schemeClr val="tx1">
+                    <a:lumMod val="50000"/>
+                    <a:lumOff val="50000"/>
+                  </a:schemeClr>
+                </a:solidFill>
+              </a:rPr>
+              <a:t>Target Hardware</a:t>
+            </a:r>
+          </a:p>
+        </p:txBody>
+      </p:sp>
+      <p:sp>
+        <p:nvSpPr>
+          <p:cNvPr id="3" name="Rectangle 2">
+            <a:extLst>
+              <a:ext uri="{FF2B5EF4-FFF2-40B4-BE49-F238E27FC236}">
+                <a16:creationId xmlns:a16="http://schemas.microsoft.com/office/drawing/2014/main" id="{35CD7B61-CF71-F47B-A3BC-616FA8E6B14D}"/>
+              </a:ext>
+            </a:extLst>
+          </p:cNvPr>
+          <p:cNvSpPr/>
+          <p:nvPr/>
+        </p:nvSpPr>
+        <p:spPr>
+          <a:xfrm>
+            <a:off x="1513700" y="1728827"/>
+            <a:ext cx="1161535" cy="883341"/>
+          </a:xfrm>
+          <a:prstGeom prst="rect">
+            <a:avLst/>
+          </a:prstGeom>
+          <a:solidFill>
+            <a:schemeClr val="accent1"/>
+          </a:solidFill>
+          <a:ln>
+            <a:noFill/>
+          </a:ln>
+        </p:spPr>
+        <p:style>
+          <a:lnRef idx="2">
+            <a:schemeClr val="accent1">
+              <a:shade val="50000"/>
+            </a:schemeClr>
+          </a:lnRef>
+          <a:fillRef idx="1">
+            <a:schemeClr val="accent1"/>
+          </a:fillRef>
+          <a:effectRef idx="0">
+            <a:schemeClr val="accent1"/>
+          </a:effectRef>
+          <a:fontRef idx="minor">
+            <a:schemeClr val="lt1"/>
+          </a:fontRef>
+        </p:style>
+        <p:txBody>
+          <a:bodyPr lIns="91440" rIns="274320" rtlCol="0" anchor="ctr"/>
+          <a:lstStyle/>
+          <a:p>
+            <a:r>
+              <a:rPr lang="en-US" sz="1200" dirty="0"/>
+              <a:t>STD I/O functions configured for UART</a:t>
+            </a:r>
+            <a:endParaRPr lang="en-US" sz="1600" dirty="0"/>
+          </a:p>
+        </p:txBody>
+      </p:sp>
+      <p:sp>
+        <p:nvSpPr>
+          <p:cNvPr id="5" name="Rectangle 4">
+            <a:extLst>
+              <a:ext uri="{FF2B5EF4-FFF2-40B4-BE49-F238E27FC236}">
+                <a16:creationId xmlns:a16="http://schemas.microsoft.com/office/drawing/2014/main" id="{FB0F9EF6-BE29-62B3-00FB-741262AEF4AC}"/>
+              </a:ext>
+            </a:extLst>
+          </p:cNvPr>
+          <p:cNvSpPr/>
+          <p:nvPr/>
+        </p:nvSpPr>
+        <p:spPr>
+          <a:xfrm>
+            <a:off x="2495891" y="1972506"/>
+            <a:ext cx="179346" cy="443643"/>
+          </a:xfrm>
+          <a:prstGeom prst="rect">
+            <a:avLst/>
+          </a:prstGeom>
+          <a:solidFill>
+            <a:schemeClr val="bg1">
+              <a:lumMod val="85000"/>
+            </a:schemeClr>
+          </a:solidFill>
+          <a:ln>
+            <a:noFill/>
+          </a:ln>
+        </p:spPr>
+        <p:style>
+          <a:lnRef idx="2">
+            <a:schemeClr val="accent1">
+              <a:shade val="50000"/>
+            </a:schemeClr>
+          </a:lnRef>
+          <a:fillRef idx="1">
+            <a:schemeClr val="accent1"/>
+          </a:fillRef>
+          <a:effectRef idx="0">
+            <a:schemeClr val="accent1"/>
+          </a:effectRef>
+          <a:fontRef idx="minor">
+            <a:schemeClr val="lt1"/>
+          </a:fontRef>
+        </p:style>
+        <p:txBody>
+          <a:bodyPr rtlCol="0" anchor="ctr"/>
+          <a:lstStyle/>
+          <a:p>
+            <a:pPr algn="ctr"/>
+            <a:endParaRPr lang="en-US"/>
+          </a:p>
+        </p:txBody>
+      </p:sp>
+      <p:sp>
+        <p:nvSpPr>
+          <p:cNvPr id="4" name="TextBox 3">
+            <a:extLst>
+              <a:ext uri="{FF2B5EF4-FFF2-40B4-BE49-F238E27FC236}">
+                <a16:creationId xmlns:a16="http://schemas.microsoft.com/office/drawing/2014/main" id="{EB2DB397-5AA5-0DC8-FA49-BC0815A7C20F}"/>
+              </a:ext>
+            </a:extLst>
+          </p:cNvPr>
+          <p:cNvSpPr txBox="1"/>
+          <p:nvPr/>
+        </p:nvSpPr>
+        <p:spPr>
+          <a:xfrm rot="16200000">
+            <a:off x="2294194" y="2108486"/>
+            <a:ext cx="635165" cy="152349"/>
+          </a:xfrm>
+          <a:prstGeom prst="rect">
+            <a:avLst/>
+          </a:prstGeom>
+          <a:noFill/>
+        </p:spPr>
+        <p:txBody>
+          <a:bodyPr wrap="square" lIns="0" tIns="0" rIns="0" bIns="0" rtlCol="0">
+            <a:spAutoFit/>
+          </a:bodyPr>
+          <a:lstStyle/>
+          <a:p>
+            <a:pPr marL="0" indent="0" algn="ctr" defTabSz="914400" rtl="0" eaLnBrk="1" latinLnBrk="0" hangingPunct="1">
+              <a:lnSpc>
+                <a:spcPct val="90000"/>
+              </a:lnSpc>
+              <a:spcBef>
+                <a:spcPts val="0"/>
+              </a:spcBef>
+              <a:spcAft>
+                <a:spcPts val="600"/>
+              </a:spcAft>
+              <a:buFont typeface="Arial" panose="020B0604020202020204" pitchFamily="34" charset="0"/>
+              <a:buNone/>
+            </a:pPr>
+            <a:r>
+              <a:rPr lang="en-US" sz="1100" kern="1200" dirty="0">
+                <a:solidFill>
+                  <a:schemeClr val="tx2"/>
+                </a:solidFill>
+                <a:latin typeface="+mn-lt"/>
+                <a:ea typeface="+mn-ea"/>
+                <a:cs typeface="+mn-cs"/>
+              </a:rPr>
+              <a:t>UART</a:t>
+            </a:r>
+          </a:p>
+        </p:txBody>
+      </p:sp>
+      <p:sp>
+        <p:nvSpPr>
+          <p:cNvPr id="7" name="Rectangle 6">
+            <a:extLst>
+              <a:ext uri="{FF2B5EF4-FFF2-40B4-BE49-F238E27FC236}">
+                <a16:creationId xmlns:a16="http://schemas.microsoft.com/office/drawing/2014/main" id="{EA8B00CF-25E1-44E5-B3E2-BA9CF1EB2434}"/>
+              </a:ext>
+            </a:extLst>
+          </p:cNvPr>
+          <p:cNvSpPr/>
+          <p:nvPr/>
+        </p:nvSpPr>
+        <p:spPr>
+          <a:xfrm>
+            <a:off x="2878354" y="1661984"/>
+            <a:ext cx="1248803" cy="1196372"/>
+          </a:xfrm>
+          <a:prstGeom prst="rect">
+            <a:avLst/>
+          </a:prstGeom>
+          <a:solidFill>
+            <a:schemeClr val="bg1">
+              <a:lumMod val="95000"/>
+            </a:schemeClr>
+          </a:solidFill>
+          <a:ln>
+            <a:noFill/>
+          </a:ln>
+        </p:spPr>
+        <p:style>
+          <a:lnRef idx="2">
+            <a:schemeClr val="accent1">
+              <a:shade val="50000"/>
+            </a:schemeClr>
+          </a:lnRef>
+          <a:fillRef idx="1">
+            <a:schemeClr val="accent1"/>
+          </a:fillRef>
+          <a:effectRef idx="0">
+            <a:schemeClr val="accent1"/>
+          </a:effectRef>
+          <a:fontRef idx="minor">
+            <a:schemeClr val="lt1"/>
+          </a:fontRef>
+        </p:style>
+        <p:txBody>
+          <a:bodyPr rtlCol="0" anchor="b"/>
+          <a:lstStyle/>
+          <a:p>
+            <a:pPr algn="ctr"/>
+            <a:r>
+              <a:rPr lang="en-US" sz="1200" dirty="0">
+                <a:solidFill>
+                  <a:schemeClr val="tx1">
+                    <a:lumMod val="50000"/>
+                    <a:lumOff val="50000"/>
+                  </a:schemeClr>
+                </a:solidFill>
+              </a:rPr>
+              <a:t>Host Computer</a:t>
+            </a:r>
+          </a:p>
+        </p:txBody>
+      </p:sp>
+      <p:sp>
+        <p:nvSpPr>
+          <p:cNvPr id="9" name="Rectangle 8">
+            <a:extLst>
+              <a:ext uri="{FF2B5EF4-FFF2-40B4-BE49-F238E27FC236}">
+                <a16:creationId xmlns:a16="http://schemas.microsoft.com/office/drawing/2014/main" id="{005A6861-6D65-6AFB-35DB-7FF318A545E9}"/>
+              </a:ext>
+            </a:extLst>
+          </p:cNvPr>
+          <p:cNvSpPr/>
+          <p:nvPr/>
+        </p:nvSpPr>
+        <p:spPr>
+          <a:xfrm>
+            <a:off x="2980191" y="1867078"/>
+            <a:ext cx="1046309" cy="745090"/>
+          </a:xfrm>
+          <a:prstGeom prst="rect">
+            <a:avLst/>
+          </a:prstGeom>
+          <a:solidFill>
+            <a:schemeClr val="accent1"/>
+          </a:solidFill>
+          <a:ln>
+            <a:noFill/>
+          </a:ln>
+        </p:spPr>
+        <p:style>
+          <a:lnRef idx="2">
+            <a:schemeClr val="accent1">
+              <a:shade val="50000"/>
+            </a:schemeClr>
+          </a:lnRef>
+          <a:fillRef idx="1">
+            <a:schemeClr val="accent1"/>
+          </a:fillRef>
+          <a:effectRef idx="0">
+            <a:schemeClr val="accent1"/>
+          </a:effectRef>
+          <a:fontRef idx="minor">
+            <a:schemeClr val="lt1"/>
+          </a:fontRef>
+        </p:style>
+        <p:txBody>
+          <a:bodyPr rtlCol="0" anchor="ctr"/>
+          <a:lstStyle/>
+          <a:p>
+            <a:pPr algn="ctr"/>
+            <a:r>
+              <a:rPr lang="en-US" sz="1200" dirty="0" err="1"/>
+              <a:t>printf</a:t>
+            </a:r>
+            <a:r>
+              <a:rPr lang="en-US" sz="1200" dirty="0"/>
+              <a:t> output </a:t>
+            </a:r>
+            <a:r>
+              <a:rPr lang="en-US" sz="1200" dirty="0" err="1"/>
+              <a:t>getchar</a:t>
+            </a:r>
+            <a:r>
+              <a:rPr lang="en-US" sz="1200" dirty="0"/>
+              <a:t> input</a:t>
+            </a:r>
+            <a:endParaRPr lang="en-US" sz="1000" i="1" dirty="0"/>
+          </a:p>
+        </p:txBody>
+      </p:sp>
+      <p:sp>
+        <p:nvSpPr>
+          <p:cNvPr id="12" name="TextBox 11">
+            <a:extLst>
+              <a:ext uri="{FF2B5EF4-FFF2-40B4-BE49-F238E27FC236}">
+                <a16:creationId xmlns:a16="http://schemas.microsoft.com/office/drawing/2014/main" id="{5299BC5D-7B84-4BD7-3DB6-F40CA52FED58}"/>
+              </a:ext>
+            </a:extLst>
+          </p:cNvPr>
+          <p:cNvSpPr txBox="1"/>
+          <p:nvPr/>
+        </p:nvSpPr>
+        <p:spPr>
+          <a:xfrm>
+            <a:off x="3149798" y="1728828"/>
+            <a:ext cx="750454" cy="276999"/>
+          </a:xfrm>
+          <a:prstGeom prst="rect">
+            <a:avLst/>
+          </a:prstGeom>
+          <a:noFill/>
+        </p:spPr>
+        <p:txBody>
+          <a:bodyPr wrap="square" lIns="0" tIns="0" rIns="0" bIns="0" rtlCol="0">
+            <a:spAutoFit/>
+          </a:bodyPr>
+          <a:lstStyle/>
+          <a:p>
+            <a:pPr marL="0" indent="0" algn="ctr" defTabSz="914400" rtl="0" eaLnBrk="1" latinLnBrk="0" hangingPunct="1">
+              <a:lnSpc>
+                <a:spcPct val="90000"/>
+              </a:lnSpc>
+              <a:spcBef>
+                <a:spcPts val="0"/>
+              </a:spcBef>
+              <a:spcAft>
+                <a:spcPts val="600"/>
+              </a:spcAft>
+              <a:buFont typeface="Arial" panose="020B0604020202020204" pitchFamily="34" charset="0"/>
+              <a:buNone/>
+            </a:pPr>
+            <a:r>
+              <a:rPr lang="en-US" sz="1000" i="1" kern="1200" dirty="0">
+                <a:solidFill>
+                  <a:schemeClr val="tx2"/>
+                </a:solidFill>
+                <a:latin typeface="+mn-lt"/>
+                <a:ea typeface="+mn-ea"/>
+                <a:cs typeface="+mn-cs"/>
+              </a:rPr>
+              <a:t>Serial Monitor</a:t>
+            </a:r>
+            <a:br>
+              <a:rPr lang="en-US" sz="1000" i="1" kern="1200" dirty="0">
+                <a:solidFill>
+                  <a:schemeClr val="tx2"/>
+                </a:solidFill>
+                <a:latin typeface="+mn-lt"/>
+                <a:ea typeface="+mn-ea"/>
+                <a:cs typeface="+mn-cs"/>
+              </a:rPr>
+            </a:br>
+            <a:endParaRPr lang="en-US" sz="1000" i="1" kern="1200" dirty="0">
+              <a:solidFill>
+                <a:schemeClr val="tx2"/>
+              </a:solidFill>
+              <a:latin typeface="+mn-lt"/>
+              <a:ea typeface="+mn-ea"/>
+              <a:cs typeface="+mn-cs"/>
+            </a:endParaRPr>
+          </a:p>
+        </p:txBody>
+      </p:sp>
+      <p:sp>
+        <p:nvSpPr>
+          <p:cNvPr id="32" name="Rectangle 31">
+            <a:extLst>
+              <a:ext uri="{FF2B5EF4-FFF2-40B4-BE49-F238E27FC236}">
+                <a16:creationId xmlns:a16="http://schemas.microsoft.com/office/drawing/2014/main" id="{D363A85F-CE8B-D734-8CFF-D8368FAEC7AF}"/>
+              </a:ext>
+            </a:extLst>
+          </p:cNvPr>
+          <p:cNvSpPr/>
+          <p:nvPr/>
+        </p:nvSpPr>
+        <p:spPr>
+          <a:xfrm>
+            <a:off x="4711350" y="1728827"/>
+            <a:ext cx="1086332" cy="883341"/>
+          </a:xfrm>
+          <a:prstGeom prst="rect">
+            <a:avLst/>
+          </a:prstGeom>
+          <a:solidFill>
+            <a:schemeClr val="accent1"/>
+          </a:solidFill>
+          <a:ln>
+            <a:noFill/>
+          </a:ln>
+        </p:spPr>
+        <p:style>
+          <a:lnRef idx="2">
+            <a:schemeClr val="accent1">
+              <a:shade val="50000"/>
+            </a:schemeClr>
+          </a:lnRef>
+          <a:fillRef idx="1">
+            <a:schemeClr val="accent1"/>
+          </a:fillRef>
+          <a:effectRef idx="0">
+            <a:schemeClr val="accent1"/>
+          </a:effectRef>
+          <a:fontRef idx="minor">
+            <a:schemeClr val="lt1"/>
+          </a:fontRef>
+        </p:style>
+        <p:txBody>
+          <a:bodyPr lIns="91440" rIns="274320" rtlCol="0" anchor="ctr"/>
+          <a:lstStyle/>
+          <a:p>
+            <a:r>
+              <a:rPr lang="en-US" sz="1200" dirty="0"/>
+              <a:t>STD I/O functions</a:t>
+            </a:r>
+          </a:p>
+          <a:p>
+            <a:r>
+              <a:rPr lang="en-US" sz="1200" dirty="0"/>
+              <a:t>configured for RTT</a:t>
+            </a:r>
+            <a:endParaRPr lang="en-US" sz="1600" dirty="0"/>
+          </a:p>
+        </p:txBody>
+      </p:sp>
+      <p:sp>
+        <p:nvSpPr>
+          <p:cNvPr id="33" name="Rectangle 32">
+            <a:extLst>
+              <a:ext uri="{FF2B5EF4-FFF2-40B4-BE49-F238E27FC236}">
+                <a16:creationId xmlns:a16="http://schemas.microsoft.com/office/drawing/2014/main" id="{DC69FD19-D137-8794-FA28-984C42B2A2E5}"/>
+              </a:ext>
+            </a:extLst>
+          </p:cNvPr>
+          <p:cNvSpPr/>
+          <p:nvPr/>
+        </p:nvSpPr>
+        <p:spPr>
+          <a:xfrm>
+            <a:off x="5590060" y="1998865"/>
+            <a:ext cx="207623" cy="403861"/>
+          </a:xfrm>
+          <a:prstGeom prst="rect">
+            <a:avLst/>
+          </a:prstGeom>
+          <a:solidFill>
+            <a:schemeClr val="bg1">
+              <a:lumMod val="85000"/>
+            </a:schemeClr>
+          </a:solidFill>
+          <a:ln>
+            <a:noFill/>
+          </a:ln>
+        </p:spPr>
+        <p:style>
+          <a:lnRef idx="2">
+            <a:schemeClr val="accent1">
+              <a:shade val="50000"/>
+            </a:schemeClr>
+          </a:lnRef>
+          <a:fillRef idx="1">
+            <a:schemeClr val="accent1"/>
+          </a:fillRef>
+          <a:effectRef idx="0">
+            <a:schemeClr val="accent1"/>
+          </a:effectRef>
+          <a:fontRef idx="minor">
+            <a:schemeClr val="lt1"/>
+          </a:fontRef>
+        </p:style>
+        <p:txBody>
+          <a:bodyPr rtlCol="0" anchor="ctr"/>
+          <a:lstStyle/>
+          <a:p>
+            <a:pPr algn="ctr"/>
+            <a:endParaRPr lang="en-US"/>
+          </a:p>
+        </p:txBody>
+      </p:sp>
+      <p:sp>
+        <p:nvSpPr>
+          <p:cNvPr id="40" name="TextBox 39">
+            <a:extLst>
+              <a:ext uri="{FF2B5EF4-FFF2-40B4-BE49-F238E27FC236}">
+                <a16:creationId xmlns:a16="http://schemas.microsoft.com/office/drawing/2014/main" id="{E0FB5D27-E228-D7AC-E780-6D21F5D6855D}"/>
+              </a:ext>
+            </a:extLst>
+          </p:cNvPr>
+          <p:cNvSpPr txBox="1"/>
+          <p:nvPr/>
+        </p:nvSpPr>
+        <p:spPr>
+          <a:xfrm rot="16200000">
+            <a:off x="5437110" y="2137314"/>
+            <a:ext cx="537669" cy="124650"/>
+          </a:xfrm>
+          <a:prstGeom prst="rect">
+            <a:avLst/>
+          </a:prstGeom>
+          <a:noFill/>
+        </p:spPr>
+        <p:txBody>
+          <a:bodyPr wrap="square" lIns="0" tIns="0" rIns="0" bIns="0" rtlCol="0">
+            <a:spAutoFit/>
+          </a:bodyPr>
+          <a:lstStyle/>
+          <a:p>
+            <a:pPr marL="0" indent="0" algn="ctr" defTabSz="914400" rtl="0" eaLnBrk="1" latinLnBrk="0" hangingPunct="1">
+              <a:lnSpc>
+                <a:spcPct val="90000"/>
+              </a:lnSpc>
+              <a:spcBef>
+                <a:spcPts val="0"/>
+              </a:spcBef>
+              <a:spcAft>
+                <a:spcPts val="600"/>
+              </a:spcAft>
+              <a:buFont typeface="Arial" panose="020B0604020202020204" pitchFamily="34" charset="0"/>
+              <a:buNone/>
+            </a:pPr>
+            <a:r>
+              <a:rPr lang="en-US" sz="900" dirty="0">
+                <a:solidFill>
+                  <a:schemeClr val="tx2"/>
+                </a:solidFill>
+              </a:rPr>
+              <a:t>Debug</a:t>
+            </a:r>
+            <a:endParaRPr lang="en-US" sz="900" kern="1200" dirty="0">
+              <a:solidFill>
+                <a:schemeClr val="tx2"/>
+              </a:solidFill>
+              <a:latin typeface="+mn-lt"/>
+              <a:ea typeface="+mn-ea"/>
+              <a:cs typeface="+mn-cs"/>
+            </a:endParaRPr>
+          </a:p>
+        </p:txBody>
+      </p:sp>
+      <p:sp>
+        <p:nvSpPr>
+          <p:cNvPr id="44" name="Arrow: Up-Down 43">
+            <a:extLst>
+              <a:ext uri="{FF2B5EF4-FFF2-40B4-BE49-F238E27FC236}">
+                <a16:creationId xmlns:a16="http://schemas.microsoft.com/office/drawing/2014/main" id="{756F2491-1893-CA72-FA86-B7BA48144BE7}"/>
+              </a:ext>
+            </a:extLst>
+          </p:cNvPr>
+          <p:cNvSpPr/>
+          <p:nvPr/>
+        </p:nvSpPr>
+        <p:spPr>
+          <a:xfrm rot="16200000">
+            <a:off x="6862748" y="2046981"/>
+            <a:ext cx="128190" cy="298391"/>
+          </a:xfrm>
+          <a:prstGeom prst="upDownArrow">
+            <a:avLst/>
+          </a:prstGeom>
+          <a:solidFill>
+            <a:schemeClr val="accent2">
+              <a:lumMod val="50000"/>
+              <a:lumOff val="50000"/>
+            </a:schemeClr>
+          </a:solidFill>
+          <a:ln>
+            <a:noFill/>
+          </a:ln>
+        </p:spPr>
+        <p:style>
+          <a:lnRef idx="2">
+            <a:schemeClr val="accent1">
+              <a:shade val="50000"/>
+            </a:schemeClr>
+          </a:lnRef>
+          <a:fillRef idx="1">
+            <a:schemeClr val="accent1"/>
+          </a:fillRef>
+          <a:effectRef idx="0">
+            <a:schemeClr val="accent1"/>
+          </a:effectRef>
+          <a:fontRef idx="minor">
+            <a:schemeClr val="lt1"/>
+          </a:fontRef>
+        </p:style>
+        <p:txBody>
+          <a:bodyPr rtlCol="0" anchor="ctr"/>
+          <a:lstStyle/>
+          <a:p>
+            <a:pPr algn="ctr"/>
+            <a:endParaRPr lang="en-US"/>
+          </a:p>
+        </p:txBody>
+      </p:sp>
+      <p:pic>
+        <p:nvPicPr>
+          <p:cNvPr id="45" name="Picture 44">
+            <a:extLst>
+              <a:ext uri="{FF2B5EF4-FFF2-40B4-BE49-F238E27FC236}">
+                <a16:creationId xmlns:a16="http://schemas.microsoft.com/office/drawing/2014/main" id="{7FBC6D61-870E-D301-DEA7-C80AFF6CC736}"/>
+              </a:ext>
+            </a:extLst>
+          </p:cNvPr>
+          <p:cNvPicPr>
+            <a:picLocks noChangeAspect="1"/>
+          </p:cNvPicPr>
+          <p:nvPr/>
+        </p:nvPicPr>
+        <p:blipFill>
+          <a:blip r:embed="rId2"/>
+          <a:stretch>
+            <a:fillRect/>
+          </a:stretch>
+        </p:blipFill>
+        <p:spPr>
+          <a:xfrm>
+            <a:off x="6092798" y="1955028"/>
+            <a:ext cx="685876" cy="485957"/>
+          </a:xfrm>
+          <a:prstGeom prst="rect">
+            <a:avLst/>
+          </a:prstGeom>
+        </p:spPr>
+      </p:pic>
+      <p:sp>
+        <p:nvSpPr>
+          <p:cNvPr id="46" name="Arrow: Up-Down 45">
+            <a:extLst>
+              <a:ext uri="{FF2B5EF4-FFF2-40B4-BE49-F238E27FC236}">
+                <a16:creationId xmlns:a16="http://schemas.microsoft.com/office/drawing/2014/main" id="{1F10E031-D56E-D751-D790-EA3465E0D658}"/>
+              </a:ext>
+            </a:extLst>
+          </p:cNvPr>
+          <p:cNvSpPr/>
+          <p:nvPr/>
+        </p:nvSpPr>
+        <p:spPr>
+          <a:xfrm rot="16200000">
+            <a:off x="5879507" y="2050443"/>
+            <a:ext cx="128190" cy="298391"/>
+          </a:xfrm>
+          <a:prstGeom prst="upDownArrow">
+            <a:avLst/>
+          </a:prstGeom>
+          <a:solidFill>
+            <a:schemeClr val="accent2">
+              <a:lumMod val="50000"/>
+              <a:lumOff val="50000"/>
+            </a:schemeClr>
+          </a:solidFill>
+          <a:ln>
+            <a:noFill/>
+          </a:ln>
+        </p:spPr>
+        <p:style>
+          <a:lnRef idx="2">
+            <a:schemeClr val="accent1">
+              <a:shade val="50000"/>
+            </a:schemeClr>
+          </a:lnRef>
+          <a:fillRef idx="1">
+            <a:schemeClr val="accent1"/>
+          </a:fillRef>
+          <a:effectRef idx="0">
+            <a:schemeClr val="accent1"/>
+          </a:effectRef>
+          <a:fontRef idx="minor">
+            <a:schemeClr val="lt1"/>
+          </a:fontRef>
+        </p:style>
+        <p:txBody>
+          <a:bodyPr rtlCol="0" anchor="ctr"/>
+          <a:lstStyle/>
+          <a:p>
+            <a:pPr algn="ctr"/>
+            <a:endParaRPr lang="en-US"/>
+          </a:p>
+        </p:txBody>
+      </p:sp>
+      <p:sp>
+        <p:nvSpPr>
+          <p:cNvPr id="25" name="Arrow: Up-Down 24">
+            <a:extLst>
+              <a:ext uri="{FF2B5EF4-FFF2-40B4-BE49-F238E27FC236}">
+                <a16:creationId xmlns:a16="http://schemas.microsoft.com/office/drawing/2014/main" id="{C1B34B12-93D2-9447-2B91-C2ED52DC591A}"/>
+              </a:ext>
+            </a:extLst>
+          </p:cNvPr>
+          <p:cNvSpPr/>
+          <p:nvPr/>
+        </p:nvSpPr>
+        <p:spPr>
+          <a:xfrm rot="16200000">
+            <a:off x="2763340" y="2051857"/>
+            <a:ext cx="128190" cy="298391"/>
+          </a:xfrm>
+          <a:prstGeom prst="upDownArrow">
+            <a:avLst/>
+          </a:prstGeom>
+          <a:solidFill>
+            <a:schemeClr val="accent2">
+              <a:lumMod val="50000"/>
+              <a:lumOff val="50000"/>
+            </a:schemeClr>
+          </a:solidFill>
+          <a:ln>
+            <a:noFill/>
+          </a:ln>
+        </p:spPr>
+        <p:style>
+          <a:lnRef idx="2">
+            <a:schemeClr val="accent1">
+              <a:shade val="50000"/>
+            </a:schemeClr>
+          </a:lnRef>
+          <a:fillRef idx="1">
+            <a:schemeClr val="accent1"/>
+          </a:fillRef>
+          <a:effectRef idx="0">
+            <a:schemeClr val="accent1"/>
+          </a:effectRef>
+          <a:fontRef idx="minor">
+            <a:schemeClr val="lt1"/>
+          </a:fontRef>
+        </p:style>
+        <p:txBody>
+          <a:bodyPr rtlCol="0" anchor="ctr"/>
+          <a:lstStyle/>
+          <a:p>
+            <a:pPr algn="ctr"/>
+            <a:endParaRPr lang="en-US"/>
+          </a:p>
+        </p:txBody>
+      </p:sp>
+      <p:sp>
+        <p:nvSpPr>
+          <p:cNvPr id="28" name="Rectangle 27">
+            <a:extLst>
+              <a:ext uri="{FF2B5EF4-FFF2-40B4-BE49-F238E27FC236}">
+                <a16:creationId xmlns:a16="http://schemas.microsoft.com/office/drawing/2014/main" id="{7A425B21-9309-684C-BB19-300CB805991C}"/>
+              </a:ext>
+            </a:extLst>
+          </p:cNvPr>
+          <p:cNvSpPr/>
+          <p:nvPr/>
+        </p:nvSpPr>
+        <p:spPr>
+          <a:xfrm>
+            <a:off x="7079262" y="1867180"/>
+            <a:ext cx="1046309" cy="745090"/>
+          </a:xfrm>
+          <a:prstGeom prst="rect">
+            <a:avLst/>
+          </a:prstGeom>
+          <a:solidFill>
+            <a:schemeClr val="accent1"/>
+          </a:solidFill>
+          <a:ln>
+            <a:noFill/>
+          </a:ln>
+        </p:spPr>
+        <p:style>
+          <a:lnRef idx="2">
+            <a:schemeClr val="accent1">
+              <a:shade val="50000"/>
+            </a:schemeClr>
+          </a:lnRef>
+          <a:fillRef idx="1">
+            <a:schemeClr val="accent1"/>
+          </a:fillRef>
+          <a:effectRef idx="0">
+            <a:schemeClr val="accent1"/>
+          </a:effectRef>
+          <a:fontRef idx="minor">
+            <a:schemeClr val="lt1"/>
+          </a:fontRef>
+        </p:style>
+        <p:txBody>
+          <a:bodyPr rtlCol="0" anchor="ctr"/>
+          <a:lstStyle/>
+          <a:p>
+            <a:pPr algn="ctr"/>
+            <a:r>
+              <a:rPr lang="en-US" sz="1200" dirty="0" err="1"/>
+              <a:t>printf</a:t>
+            </a:r>
+            <a:r>
+              <a:rPr lang="en-US" sz="1200" dirty="0"/>
+              <a:t> output </a:t>
+            </a:r>
+            <a:r>
+              <a:rPr lang="en-US" sz="1200" dirty="0" err="1"/>
+              <a:t>getchar</a:t>
+            </a:r>
+            <a:r>
+              <a:rPr lang="en-US" sz="1200" dirty="0"/>
+              <a:t> input</a:t>
+            </a:r>
+            <a:endParaRPr lang="en-US" sz="1000" i="1" dirty="0"/>
+          </a:p>
+        </p:txBody>
+      </p:sp>
+      <p:sp>
+        <p:nvSpPr>
+          <p:cNvPr id="31" name="TextBox 30">
+            <a:extLst>
+              <a:ext uri="{FF2B5EF4-FFF2-40B4-BE49-F238E27FC236}">
+                <a16:creationId xmlns:a16="http://schemas.microsoft.com/office/drawing/2014/main" id="{88A69E53-064D-451D-6ACE-4A40192B3C7A}"/>
+              </a:ext>
+            </a:extLst>
+          </p:cNvPr>
+          <p:cNvSpPr txBox="1"/>
+          <p:nvPr/>
+        </p:nvSpPr>
+        <p:spPr>
+          <a:xfrm>
+            <a:off x="7248869" y="1728930"/>
+            <a:ext cx="750454" cy="276999"/>
+          </a:xfrm>
+          <a:prstGeom prst="rect">
+            <a:avLst/>
+          </a:prstGeom>
+          <a:noFill/>
+        </p:spPr>
+        <p:txBody>
+          <a:bodyPr wrap="square" lIns="0" tIns="0" rIns="0" bIns="0" rtlCol="0">
+            <a:spAutoFit/>
+          </a:bodyPr>
+          <a:lstStyle/>
+          <a:p>
+            <a:pPr marL="0" indent="0" algn="ctr" defTabSz="914400" rtl="0" eaLnBrk="1" latinLnBrk="0" hangingPunct="1">
+              <a:lnSpc>
+                <a:spcPct val="90000"/>
+              </a:lnSpc>
+              <a:spcBef>
+                <a:spcPts val="0"/>
+              </a:spcBef>
+              <a:spcAft>
+                <a:spcPts val="600"/>
+              </a:spcAft>
+              <a:buFont typeface="Arial" panose="020B0604020202020204" pitchFamily="34" charset="0"/>
+              <a:buNone/>
+            </a:pPr>
+            <a:r>
+              <a:rPr lang="en-US" sz="1000" i="1" kern="1200" dirty="0">
+                <a:solidFill>
+                  <a:schemeClr val="tx2"/>
+                </a:solidFill>
+                <a:latin typeface="+mn-lt"/>
+                <a:ea typeface="+mn-ea"/>
+                <a:cs typeface="+mn-cs"/>
+              </a:rPr>
+              <a:t>Serial Monitor</a:t>
+            </a:r>
+            <a:br>
+              <a:rPr lang="en-US" sz="1000" i="1" kern="1200" dirty="0">
+                <a:solidFill>
+                  <a:schemeClr val="tx2"/>
+                </a:solidFill>
+                <a:latin typeface="+mn-lt"/>
+                <a:ea typeface="+mn-ea"/>
+                <a:cs typeface="+mn-cs"/>
+              </a:rPr>
+            </a:br>
+            <a:endParaRPr lang="en-US" sz="1000" i="1" kern="1200" dirty="0">
+              <a:solidFill>
+                <a:schemeClr val="tx2"/>
+              </a:solidFill>
+              <a:latin typeface="+mn-lt"/>
+              <a:ea typeface="+mn-ea"/>
+              <a:cs typeface="+mn-cs"/>
+            </a:endParaRPr>
+          </a:p>
+        </p:txBody>
+      </p:sp>
+      <p:sp>
+        <p:nvSpPr>
+          <p:cNvPr id="41" name="TextBox 40">
+            <a:extLst>
+              <a:ext uri="{FF2B5EF4-FFF2-40B4-BE49-F238E27FC236}">
+                <a16:creationId xmlns:a16="http://schemas.microsoft.com/office/drawing/2014/main" id="{0E24869C-94AA-EB77-64DB-2C905BB5ADE3}"/>
+              </a:ext>
+            </a:extLst>
+          </p:cNvPr>
+          <p:cNvSpPr txBox="1"/>
+          <p:nvPr/>
+        </p:nvSpPr>
+        <p:spPr>
+          <a:xfrm>
+            <a:off x="1393835" y="1365734"/>
+            <a:ext cx="2733322" cy="276999"/>
+          </a:xfrm>
+          <a:prstGeom prst="rect">
+            <a:avLst/>
+          </a:prstGeom>
+          <a:noFill/>
+        </p:spPr>
+        <p:txBody>
+          <a:bodyPr wrap="square" rtlCol="0">
+            <a:spAutoFit/>
+          </a:bodyPr>
+          <a:lstStyle/>
+          <a:p>
+            <a:pPr algn="ctr"/>
+            <a:r>
+              <a:rPr lang="en-US" sz="1200" dirty="0"/>
+              <a:t>I/O via UART Peripheral</a:t>
+            </a:r>
+          </a:p>
+        </p:txBody>
+      </p:sp>
+      <p:sp>
+        <p:nvSpPr>
+          <p:cNvPr id="42" name="TextBox 41">
+            <a:extLst>
+              <a:ext uri="{FF2B5EF4-FFF2-40B4-BE49-F238E27FC236}">
+                <a16:creationId xmlns:a16="http://schemas.microsoft.com/office/drawing/2014/main" id="{8BE0BAE9-DC01-3B3C-9050-7CB6C3309653}"/>
+              </a:ext>
+            </a:extLst>
+          </p:cNvPr>
+          <p:cNvSpPr txBox="1"/>
+          <p:nvPr/>
+        </p:nvSpPr>
+        <p:spPr>
+          <a:xfrm>
+            <a:off x="4511857" y="1373432"/>
+            <a:ext cx="3714371" cy="276999"/>
+          </a:xfrm>
+          <a:prstGeom prst="rect">
+            <a:avLst/>
+          </a:prstGeom>
+          <a:noFill/>
+        </p:spPr>
+        <p:txBody>
+          <a:bodyPr wrap="square" rtlCol="0">
+            <a:spAutoFit/>
+          </a:bodyPr>
+          <a:lstStyle/>
+          <a:p>
+            <a:pPr algn="ctr"/>
+            <a:r>
+              <a:rPr lang="en-US" sz="1200" dirty="0"/>
+              <a:t>I/O via Debug Unit</a:t>
+            </a:r>
+          </a:p>
+        </p:txBody>
+      </p:sp>
+      <p:cxnSp>
+        <p:nvCxnSpPr>
+          <p:cNvPr id="47" name="Straight Connector 46">
+            <a:extLst>
+              <a:ext uri="{FF2B5EF4-FFF2-40B4-BE49-F238E27FC236}">
+                <a16:creationId xmlns:a16="http://schemas.microsoft.com/office/drawing/2014/main" id="{9E77E39D-2467-64B8-858D-1281B8815437}"/>
+              </a:ext>
+            </a:extLst>
+          </p:cNvPr>
+          <p:cNvCxnSpPr>
+            <a:cxnSpLocks/>
+          </p:cNvCxnSpPr>
+          <p:nvPr/>
+        </p:nvCxnSpPr>
+        <p:spPr>
+          <a:xfrm>
+            <a:off x="4380471" y="1365734"/>
+            <a:ext cx="0" cy="1674028"/>
+          </a:xfrm>
+          <a:prstGeom prst="line">
+            <a:avLst/>
+          </a:prstGeom>
+        </p:spPr>
+        <p:style>
+          <a:lnRef idx="1">
+            <a:schemeClr val="accent1"/>
+          </a:lnRef>
+          <a:fillRef idx="0">
+            <a:schemeClr val="accent1"/>
+          </a:fillRef>
+          <a:effectRef idx="0">
+            <a:schemeClr val="accent1"/>
+          </a:effectRef>
+          <a:fontRef idx="minor">
+            <a:schemeClr val="tx1"/>
+          </a:fontRef>
+        </p:style>
+      </p:cxnSp>
+    </p:spTree>
+    <p:extLst>
+      <p:ext uri="{BB962C8B-B14F-4D97-AF65-F5344CB8AC3E}">
+        <p14:creationId xmlns:p14="http://schemas.microsoft.com/office/powerpoint/2010/main" val="3268438185"/>
+      </p:ext>
+    </p:extLst>
+  </p:cSld>
+  <p:clrMapOvr>
+    <a:masterClrMapping/>
+  </p:clrMapOvr>
+</p:sld>
+</file>
+
 <file path=ppt/theme/theme1.xml><?xml version="1.0" encoding="utf-8"?>
 <a:theme xmlns:a="http://schemas.openxmlformats.org/drawingml/2006/main" name="Office Theme">
   <a:themeElements>

</xml_diff>